<commit_message>
talk(v3): drop 'pencil' language; redraw τ(v) with realistic Sherwood structure
User feedback: 'Don't use analytical terms like 1D pencils. What the hell?
Just say ray.' Plus: τ(v) panel should match a real Sherwood spectrum
(sparse sharp peaks on near-zero baseline), not the hill-shaped cartoon.

- cosmological_setup.png: redrew the bottom panel from scratch. Now
  near-zero baseline (~0.02), 15 narrow Gaussian absorbers of varying
  heights, one dominant absorber at v_obs ≈ 2640 km/s, three-peak
  cluster on the right edge — matches the visual structure of an
  actual Sherwood τ(v) profile at z = 0.3.
- 'sightline (1D pencil through the volume)' → 'sightline (ray through
  the volume)' in the figure annotation.
- Slide 2 caption + speaker notes: 'pencils' / 'pencil through 3D
  structure' replaced with 'sightline' / 'ray' throughout.

Co-Authored-By: Claude Opus 4.7 (1M context) <noreply@anthropic.com>
</commit_message>
<xml_diff>
--- a/experiments/nerf/talk/defense_talk_5min.pptx
+++ b/experiments/nerf/talk/defense_talk_5min.pptx
@@ -709,17 +709,17 @@
           <a:p/>
           <a:p>
             <a:r>
-              <a:t>Surveys like DESI will give us millions of these spectra. Each one is a 1D</a:t>
-            </a:r>
-          </a:p>
-          <a:p>
-            <a:r>
-              <a:t>pencil through 3D structure. The reconstruction question is: how do we</a:t>
-            </a:r>
-          </a:p>
-          <a:p>
-            <a:r>
-              <a:t>recover the 3D fields from these pencils?</a:t>
+              <a:t>Surveys like DESI will give us millions of these spectra — one ray, one</a:t>
+            </a:r>
+          </a:p>
+          <a:p>
+            <a:r>
+              <a:t>spectrum. The reconstruction question is: how do we recover the 3D fields</a:t>
+            </a:r>
+          </a:p>
+          <a:p>
+            <a:r>
+              <a:t>from a few hundred to a few thousand of these rays?</a:t>
             </a:r>
           </a:p>
         </p:txBody>
@@ -4785,7 +4785,7 @@
                   <a:srgbClr val="102A43"/>
                 </a:solidFill>
               </a:rPr>
-              <a:t>Each spectrum is a 1D pencil through a 3D scene  —  thousands of pencils is what we have to reconstruct the volume.</a:t>
+              <a:t>Each sightline gives us one absorption spectrum  —  thousands of rays is what we have to reconstruct the volume.</a:t>
             </a:r>
           </a:p>
         </p:txBody>

</xml_diff>